<commit_message>
deck: sync with outdoor rename (title, repo urls)
</commit_message>
<xml_diff>
--- a/docs/CS5330_final_presentation.pptx
+++ b/docs/CS5330_final_presentation.pptx
@@ -3241,13 +3241,13 @@
           <a:p>
             <a:pPr algn="l"/>
             <a:r>
-              <a:rPr sz="5400" b="1">
+              <a:rPr sz="4800" b="1">
                 <a:solidFill>
                   <a:srgbClr val="E8E8EE"/>
                 </a:solidFill>
                 <a:latin typeface="Helvetica Neue"/>
               </a:rPr>
-              <a:t>3DGS Indoor Reconstruction</a:t>
+              <a:t>3DGS Outdoor Reconstruction</a:t>
             </a:r>
           </a:p>
         </p:txBody>
@@ -3675,7 +3675,7 @@
                 </a:solidFill>
                 <a:latin typeface="Menlo"/>
               </a:rPr>
-              <a:t>github.com/Meetjain-0201/3dgs-indoor-reconstruction</a:t>
+              <a:t>github.com/Meetjain-0201/3dgs-outdoor-reconstruction</a:t>
             </a:r>
           </a:p>
         </p:txBody>
@@ -9668,7 +9668,7 @@
                 </a:solidFill>
                 <a:latin typeface="Menlo"/>
               </a:rPr>
-              <a:t>repo  →  github.com/Meetjain-0201/3dgs-indoor-reconstruction</a:t>
+              <a:t>repo  →  github.com/Meetjain-0201/3dgs-outdoor-reconstruction</a:t>
             </a:r>
           </a:p>
         </p:txBody>

</xml_diff>